<commit_message>
Remove VPC flow logs: drop FlowLogBucket + VpcFlowLog from template and all deliverables
- Template: delete S3 bucket and flow log resources, keep template lint-clean
- README: drop flow-log rows/bullets, cfn-guard findings now 9 (was 14)
- Deliverables: remove flow-log chips/bullets/rows from PPTX, EXCEL, DOCX
- Doc generator regenerated
</commit_message>
<xml_diff>
--- a/deliverables/AWS-Architecture-Design-Document.pptx
+++ b/deliverables/AWS-Architecture-Design-Document.pptx
@@ -5982,18 +5982,440 @@
       </p:sp>
       <p:sp>
         <p:nvSpPr>
-          <p:cNvPr id="17" name="Rounded Rectangle 16"/>
+          <p:cNvPr id="17" name="TextBox 16"/>
+          <p:cNvSpPr txBox="1"/>
+          <p:nvPr/>
+        </p:nvSpPr>
+        <p:spPr>
+          <a:xfrm>
+            <a:off x="3063240" y="5468112"/>
+            <a:ext cx="6035040" cy="274320"/>
+          </a:xfrm>
+          <a:prstGeom prst="rect">
+            <a:avLst/>
+          </a:prstGeom>
+          <a:noFill/>
+        </p:spPr>
+        <p:txBody>
+          <a:bodyPr wrap="square" anchor="t" lIns="25400" rIns="25400" tIns="12700" bIns="12700">
+            <a:spAutoFit/>
+          </a:bodyPr>
+          <a:lstStyle/>
+          <a:p>
+            <a:pPr algn="l"/>
+            <a:r>
+              <a:rPr sz="1000" b="0" i="0">
+                <a:solidFill>
+                  <a:srgbClr val="9AA7B4"/>
+                </a:solidFill>
+                <a:latin typeface="Calibri"/>
+              </a:rPr>
+              <a:t>Client VPN logs → CloudWatch (90 d) · AWS API access via VPC interface endpoints only</a:t>
+            </a:r>
+          </a:p>
+        </p:txBody>
+      </p:sp>
+      <p:sp>
+        <p:nvSpPr>
+          <p:cNvPr id="18" name="Rounded Rectangle 17"/>
           <p:cNvSpPr/>
           <p:nvPr/>
         </p:nvSpPr>
         <p:spPr>
           <a:xfrm>
-            <a:off x="7616952" y="4864608"/>
-            <a:ext cx="1426464" cy="457200"/>
+            <a:off x="9555480" y="2377440"/>
+            <a:ext cx="2331720" cy="960120"/>
+          </a:xfrm>
+          <a:prstGeom prst="roundRect">
+            <a:avLst>
+              <a:gd name="adj" fmla="val 8000"/>
+            </a:avLst>
+          </a:prstGeom>
+          <a:solidFill>
+            <a:srgbClr val="F2F2F2"/>
+          </a:solidFill>
+          <a:ln w="12700">
+            <a:solidFill>
+              <a:srgbClr val="595959"/>
+            </a:solidFill>
+          </a:ln>
+          <a:effectLst/>
+        </p:spPr>
+        <p:style>
+          <a:lnRef idx="1">
+            <a:schemeClr val="accent1"/>
+          </a:lnRef>
+          <a:fillRef idx="3">
+            <a:schemeClr val="accent1"/>
+          </a:fillRef>
+          <a:effectRef idx="2">
+            <a:schemeClr val="accent1"/>
+          </a:effectRef>
+          <a:fontRef idx="minor">
+            <a:schemeClr val="lt1"/>
+          </a:fontRef>
+        </p:style>
+        <p:txBody>
+          <a:bodyPr rtlCol="0" anchor="ctr"/>
+          <a:lstStyle/>
+          <a:p>
+            <a:pPr algn="ctr"/>
+          </a:p>
+        </p:txBody>
+      </p:sp>
+      <p:sp>
+        <p:nvSpPr>
+          <p:cNvPr id="19" name="TextBox 18"/>
+          <p:cNvSpPr txBox="1"/>
+          <p:nvPr/>
+        </p:nvSpPr>
+        <p:spPr>
+          <a:xfrm>
+            <a:off x="9692640" y="2487168"/>
+            <a:ext cx="2103120" cy="292608"/>
+          </a:xfrm>
+          <a:prstGeom prst="rect">
+            <a:avLst/>
+          </a:prstGeom>
+          <a:noFill/>
+        </p:spPr>
+        <p:txBody>
+          <a:bodyPr wrap="square" anchor="t" lIns="25400" rIns="25400" tIns="12700" bIns="12700">
+            <a:spAutoFit/>
+          </a:bodyPr>
+          <a:lstStyle/>
+          <a:p>
+            <a:pPr algn="l"/>
+            <a:r>
+              <a:rPr sz="1300" b="1" i="0">
+                <a:solidFill>
+                  <a:srgbClr val="002C5F"/>
+                </a:solidFill>
+                <a:latin typeface="Calibri"/>
+              </a:rPr>
+              <a:t>On-prem racing site</a:t>
+            </a:r>
+          </a:p>
+        </p:txBody>
+      </p:sp>
+      <p:sp>
+        <p:nvSpPr>
+          <p:cNvPr id="20" name="TextBox 19"/>
+          <p:cNvSpPr txBox="1"/>
+          <p:nvPr/>
+        </p:nvSpPr>
+        <p:spPr>
+          <a:xfrm>
+            <a:off x="9692640" y="2788920"/>
+            <a:ext cx="2103120" cy="457200"/>
+          </a:xfrm>
+          <a:prstGeom prst="rect">
+            <a:avLst/>
+          </a:prstGeom>
+          <a:noFill/>
+        </p:spPr>
+        <p:txBody>
+          <a:bodyPr wrap="square" anchor="t" lIns="25400" rIns="25400" tIns="12700" bIns="12700">
+            <a:spAutoFit/>
+          </a:bodyPr>
+          <a:lstStyle/>
+          <a:p>
+            <a:pPr algn="l"/>
+            <a:r>
+              <a:rPr sz="1050" b="0" i="0">
+                <a:solidFill>
+                  <a:srgbClr val="595959"/>
+                </a:solidFill>
+                <a:latin typeface="Calibri"/>
+              </a:rPr>
+              <a:t>Hyundai firewall</a:t>
+            </a:r>
+          </a:p>
+          <a:p>
+            <a:pPr algn="l"/>
+            <a:r>
+              <a:rPr sz="1050" b="0" i="0">
+                <a:solidFill>
+                  <a:srgbClr val="595959"/>
+                </a:solidFill>
+                <a:latin typeface="Calibri"/>
+              </a:rPr>
+              <a:t>IPsec.1 · static</a:t>
+            </a:r>
+          </a:p>
+        </p:txBody>
+      </p:sp>
+      <p:sp>
+        <p:nvSpPr>
+          <p:cNvPr id="21" name="Rounded Rectangle 20"/>
+          <p:cNvSpPr/>
+          <p:nvPr/>
+        </p:nvSpPr>
+        <p:spPr>
+          <a:xfrm>
+            <a:off x="9317736" y="3035808"/>
+            <a:ext cx="502920" cy="274320"/>
           </a:xfrm>
           <a:prstGeom prst="roundRect">
             <a:avLst>
               <a:gd name="adj" fmla="val 50000"/>
+            </a:avLst>
+          </a:prstGeom>
+          <a:solidFill>
+            <a:srgbClr val="002C5F"/>
+          </a:solidFill>
+          <a:ln>
+            <a:noFill/>
+          </a:ln>
+          <a:effectLst/>
+        </p:spPr>
+        <p:style>
+          <a:lnRef idx="1">
+            <a:schemeClr val="accent1"/>
+          </a:lnRef>
+          <a:fillRef idx="3">
+            <a:schemeClr val="accent1"/>
+          </a:fillRef>
+          <a:effectRef idx="2">
+            <a:schemeClr val="accent1"/>
+          </a:effectRef>
+          <a:fontRef idx="minor">
+            <a:schemeClr val="lt1"/>
+          </a:fontRef>
+        </p:style>
+        <p:txBody>
+          <a:bodyPr rtlCol="0" anchor="ctr" wrap="square" lIns="38100" rIns="38100"/>
+          <a:lstStyle/>
+          <a:p>
+            <a:pPr algn="ctr"/>
+            <a:r>
+              <a:rPr sz="900" b="1" i="0">
+                <a:solidFill>
+                  <a:srgbClr val="FFFFFF"/>
+                </a:solidFill>
+                <a:latin typeface="Calibri"/>
+              </a:rPr>
+              <a:t>VGW</a:t>
+            </a:r>
+          </a:p>
+        </p:txBody>
+      </p:sp>
+      <p:cxnSp>
+        <p:nvCxnSpPr>
+          <p:cNvPr id="22" name="Connector 21"/>
+          <p:cNvCxnSpPr/>
+          <p:nvPr/>
+        </p:nvCxnSpPr>
+        <p:spPr>
+          <a:xfrm>
+            <a:off x="9555480" y="2862072"/>
+            <a:ext cx="155448" cy="292608"/>
+          </a:xfrm>
+          <a:prstGeom prst="line">
+            <a:avLst/>
+          </a:prstGeom>
+          <a:ln w="22225">
+            <a:solidFill>
+              <a:srgbClr val="595959"/>
+            </a:solidFill>
+            <a:prstDash val="dash"/>
+            <a:tailEnd type="triangle" w="med" len="med"/>
+          </a:ln>
+        </p:spPr>
+        <p:style>
+          <a:lnRef idx="2">
+            <a:schemeClr val="accent1"/>
+          </a:lnRef>
+          <a:fillRef idx="0">
+            <a:schemeClr val="accent1"/>
+          </a:fillRef>
+          <a:effectRef idx="1">
+            <a:schemeClr val="accent1"/>
+          </a:effectRef>
+          <a:fontRef idx="minor">
+            <a:schemeClr val="tx1"/>
+          </a:fontRef>
+        </p:style>
+      </p:cxnSp>
+      <p:sp>
+        <p:nvSpPr>
+          <p:cNvPr id="23" name="TextBox 22"/>
+          <p:cNvSpPr txBox="1"/>
+          <p:nvPr/>
+        </p:nvSpPr>
+        <p:spPr>
+          <a:xfrm>
+            <a:off x="9464040" y="3429000"/>
+            <a:ext cx="2377440" cy="502920"/>
+          </a:xfrm>
+          <a:prstGeom prst="rect">
+            <a:avLst/>
+          </a:prstGeom>
+          <a:noFill/>
+        </p:spPr>
+        <p:txBody>
+          <a:bodyPr wrap="square" anchor="t" lIns="25400" rIns="25400" tIns="12700" bIns="12700">
+            <a:spAutoFit/>
+          </a:bodyPr>
+          <a:lstStyle/>
+          <a:p>
+            <a:pPr algn="l"/>
+            <a:r>
+              <a:rPr sz="1000" b="0" i="0">
+                <a:solidFill>
+                  <a:srgbClr val="9AA7B4"/>
+                </a:solidFill>
+                <a:latin typeface="Calibri"/>
+              </a:rPr>
+              <a:t>Site-to-Site VPN</a:t>
+            </a:r>
+          </a:p>
+          <a:p>
+            <a:pPr algn="l"/>
+            <a:r>
+              <a:rPr sz="1000" b="0" i="0">
+                <a:solidFill>
+                  <a:srgbClr val="9AA7B4"/>
+                </a:solidFill>
+                <a:latin typeface="Calibri"/>
+              </a:rPr>
+              <a:t>only when on-prem values are supplied</a:t>
+            </a:r>
+          </a:p>
+        </p:txBody>
+      </p:sp>
+      <p:sp>
+        <p:nvSpPr>
+          <p:cNvPr id="24" name="Rounded Rectangle 23"/>
+          <p:cNvSpPr/>
+          <p:nvPr/>
+        </p:nvSpPr>
+        <p:spPr>
+          <a:xfrm>
+            <a:off x="457200" y="1920240"/>
+            <a:ext cx="2011680" cy="822960"/>
+          </a:xfrm>
+          <a:prstGeom prst="roundRect">
+            <a:avLst>
+              <a:gd name="adj" fmla="val 8000"/>
+            </a:avLst>
+          </a:prstGeom>
+          <a:solidFill>
+            <a:srgbClr val="F2F2F2"/>
+          </a:solidFill>
+          <a:ln w="12700">
+            <a:solidFill>
+              <a:srgbClr val="595959"/>
+            </a:solidFill>
+          </a:ln>
+          <a:effectLst/>
+        </p:spPr>
+        <p:style>
+          <a:lnRef idx="1">
+            <a:schemeClr val="accent1"/>
+          </a:lnRef>
+          <a:fillRef idx="3">
+            <a:schemeClr val="accent1"/>
+          </a:fillRef>
+          <a:effectRef idx="2">
+            <a:schemeClr val="accent1"/>
+          </a:effectRef>
+          <a:fontRef idx="minor">
+            <a:schemeClr val="lt1"/>
+          </a:fontRef>
+        </p:style>
+        <p:txBody>
+          <a:bodyPr rtlCol="0" anchor="ctr"/>
+          <a:lstStyle/>
+          <a:p>
+            <a:pPr algn="ctr"/>
+          </a:p>
+        </p:txBody>
+      </p:sp>
+      <p:sp>
+        <p:nvSpPr>
+          <p:cNvPr id="25" name="TextBox 24"/>
+          <p:cNvSpPr txBox="1"/>
+          <p:nvPr/>
+        </p:nvSpPr>
+        <p:spPr>
+          <a:xfrm>
+            <a:off x="594360" y="2029968"/>
+            <a:ext cx="1783080" cy="274320"/>
+          </a:xfrm>
+          <a:prstGeom prst="rect">
+            <a:avLst/>
+          </a:prstGeom>
+          <a:noFill/>
+        </p:spPr>
+        <p:txBody>
+          <a:bodyPr wrap="square" anchor="t" lIns="25400" rIns="25400" tIns="12700" bIns="12700">
+            <a:spAutoFit/>
+          </a:bodyPr>
+          <a:lstStyle/>
+          <a:p>
+            <a:pPr algn="l"/>
+            <a:r>
+              <a:rPr sz="1300" b="1" i="0">
+                <a:solidFill>
+                  <a:srgbClr val="002C5F"/>
+                </a:solidFill>
+                <a:latin typeface="Calibri"/>
+              </a:rPr>
+              <a:t>Developers (≤10)</a:t>
+            </a:r>
+          </a:p>
+        </p:txBody>
+      </p:sp>
+      <p:sp>
+        <p:nvSpPr>
+          <p:cNvPr id="26" name="TextBox 25"/>
+          <p:cNvSpPr txBox="1"/>
+          <p:nvPr/>
+        </p:nvSpPr>
+        <p:spPr>
+          <a:xfrm>
+            <a:off x="594360" y="2331720"/>
+            <a:ext cx="1783080" cy="365760"/>
+          </a:xfrm>
+          <a:prstGeom prst="rect">
+            <a:avLst/>
+          </a:prstGeom>
+          <a:noFill/>
+        </p:spPr>
+        <p:txBody>
+          <a:bodyPr wrap="square" anchor="t" lIns="25400" rIns="25400" tIns="12700" bIns="12700">
+            <a:spAutoFit/>
+          </a:bodyPr>
+          <a:lstStyle/>
+          <a:p>
+            <a:pPr algn="l"/>
+            <a:r>
+              <a:rPr sz="1050" b="0" i="0">
+                <a:solidFill>
+                  <a:srgbClr val="595959"/>
+                </a:solidFill>
+                <a:latin typeface="Calibri"/>
+              </a:rPr>
+              <a:t>Entra ID SSO · MFA</a:t>
+            </a:r>
+          </a:p>
+        </p:txBody>
+      </p:sp>
+      <p:sp>
+        <p:nvSpPr>
+          <p:cNvPr id="27" name="Rounded Rectangle 26"/>
+          <p:cNvSpPr/>
+          <p:nvPr/>
+        </p:nvSpPr>
+        <p:spPr>
+          <a:xfrm>
+            <a:off x="457200" y="3291840"/>
+            <a:ext cx="2011680" cy="1005840"/>
+          </a:xfrm>
+          <a:prstGeom prst="roundRect">
+            <a:avLst>
+              <a:gd name="adj" fmla="val 8000"/>
             </a:avLst>
           </a:prstGeom>
           <a:solidFill>
@@ -6021,32 +6443,23 @@
           </a:fontRef>
         </p:style>
         <p:txBody>
-          <a:bodyPr rtlCol="0" anchor="ctr" wrap="square" lIns="38100" rIns="38100"/>
+          <a:bodyPr rtlCol="0" anchor="ctr"/>
           <a:lstStyle/>
           <a:p>
             <a:pPr algn="ctr"/>
-            <a:r>
-              <a:rPr sz="1100" b="1" i="0">
-                <a:solidFill>
-                  <a:srgbClr val="002C5F"/>
-                </a:solidFill>
-                <a:latin typeface="Calibri"/>
-              </a:rPr>
-              <a:t>S3 — flow logs</a:t>
-            </a:r>
-          </a:p>
-        </p:txBody>
-      </p:sp>
-      <p:sp>
-        <p:nvSpPr>
-          <p:cNvPr id="18" name="TextBox 17"/>
+          </a:p>
+        </p:txBody>
+      </p:sp>
+      <p:sp>
+        <p:nvSpPr>
+          <p:cNvPr id="28" name="TextBox 27"/>
           <p:cNvSpPr txBox="1"/>
           <p:nvPr/>
         </p:nvSpPr>
         <p:spPr>
           <a:xfrm>
-            <a:off x="3063240" y="5468112"/>
-            <a:ext cx="6035040" cy="274320"/>
+            <a:off x="594360" y="3401568"/>
+            <a:ext cx="1783080" cy="274320"/>
           </a:xfrm>
           <a:prstGeom prst="rect">
             <a:avLst/>
@@ -6061,75 +6474,27 @@
           <a:p>
             <a:pPr algn="l"/>
             <a:r>
-              <a:rPr sz="1000" b="0" i="0">
-                <a:solidFill>
-                  <a:srgbClr val="9AA7B4"/>
-                </a:solidFill>
-                <a:latin typeface="Calibri"/>
-              </a:rPr>
-              <a:t>Flow logs → S3 (lifecycle 30d → Glacier, expire 1y) · Client VPN logs → CloudWatch (90d)</a:t>
-            </a:r>
-          </a:p>
-        </p:txBody>
-      </p:sp>
-      <p:sp>
-        <p:nvSpPr>
-          <p:cNvPr id="19" name="Rounded Rectangle 18"/>
-          <p:cNvSpPr/>
-          <p:nvPr/>
-        </p:nvSpPr>
-        <p:spPr>
-          <a:xfrm>
-            <a:off x="9555480" y="2377440"/>
-            <a:ext cx="2331720" cy="960120"/>
-          </a:xfrm>
-          <a:prstGeom prst="roundRect">
-            <a:avLst>
-              <a:gd name="adj" fmla="val 8000"/>
-            </a:avLst>
-          </a:prstGeom>
-          <a:solidFill>
-            <a:srgbClr val="F2F2F2"/>
-          </a:solidFill>
-          <a:ln w="12700">
-            <a:solidFill>
-              <a:srgbClr val="595959"/>
-            </a:solidFill>
-          </a:ln>
-          <a:effectLst/>
-        </p:spPr>
-        <p:style>
-          <a:lnRef idx="1">
-            <a:schemeClr val="accent1"/>
-          </a:lnRef>
-          <a:fillRef idx="3">
-            <a:schemeClr val="accent1"/>
-          </a:fillRef>
-          <a:effectRef idx="2">
-            <a:schemeClr val="accent1"/>
-          </a:effectRef>
-          <a:fontRef idx="minor">
-            <a:schemeClr val="lt1"/>
-          </a:fontRef>
-        </p:style>
-        <p:txBody>
-          <a:bodyPr rtlCol="0" anchor="ctr"/>
-          <a:lstStyle/>
-          <a:p>
-            <a:pPr algn="ctr"/>
-          </a:p>
-        </p:txBody>
-      </p:sp>
-      <p:sp>
-        <p:nvSpPr>
-          <p:cNvPr id="20" name="TextBox 19"/>
+              <a:rPr sz="1300" b="1" i="0">
+                <a:solidFill>
+                  <a:srgbClr val="002C5F"/>
+                </a:solidFill>
+                <a:latin typeface="Calibri"/>
+              </a:rPr>
+              <a:t>AWS Client VPN</a:t>
+            </a:r>
+          </a:p>
+        </p:txBody>
+      </p:sp>
+      <p:sp>
+        <p:nvSpPr>
+          <p:cNvPr id="29" name="TextBox 28"/>
           <p:cNvSpPr txBox="1"/>
           <p:nvPr/>
         </p:nvSpPr>
         <p:spPr>
           <a:xfrm>
-            <a:off x="9692640" y="2487168"/>
-            <a:ext cx="2103120" cy="292608"/>
+            <a:off x="594360" y="3703320"/>
+            <a:ext cx="1783080" cy="502920"/>
           </a:xfrm>
           <a:prstGeom prst="rect">
             <a:avLst/>
@@ -6144,38 +6509,15 @@
           <a:p>
             <a:pPr algn="l"/>
             <a:r>
-              <a:rPr sz="1300" b="1" i="0">
-                <a:solidFill>
-                  <a:srgbClr val="002C5F"/>
-                </a:solidFill>
-                <a:latin typeface="Calibri"/>
-              </a:rPr>
-              <a:t>On-prem racing site</a:t>
-            </a:r>
-          </a:p>
-        </p:txBody>
-      </p:sp>
-      <p:sp>
-        <p:nvSpPr>
-          <p:cNvPr id="21" name="TextBox 20"/>
-          <p:cNvSpPr txBox="1"/>
-          <p:nvPr/>
-        </p:nvSpPr>
-        <p:spPr>
-          <a:xfrm>
-            <a:off x="9692640" y="2788920"/>
-            <a:ext cx="2103120" cy="457200"/>
-          </a:xfrm>
-          <a:prstGeom prst="rect">
-            <a:avLst/>
-          </a:prstGeom>
-          <a:noFill/>
-        </p:spPr>
-        <p:txBody>
-          <a:bodyPr wrap="square" anchor="t" lIns="25400" rIns="25400" tIns="12700" bIns="12700">
-            <a:spAutoFit/>
-          </a:bodyPr>
-          <a:lstStyle/>
+              <a:rPr sz="1050" b="0" i="0">
+                <a:solidFill>
+                  <a:srgbClr val="595959"/>
+                </a:solidFill>
+                <a:latin typeface="Calibri"/>
+              </a:rPr>
+              <a:t>UDP 443 · SAML</a:t>
+            </a:r>
+          </a:p>
           <a:p>
             <a:pPr algn="l"/>
             <a:r>
@@ -6185,413 +6527,14 @@
                 </a:solidFill>
                 <a:latin typeface="Calibri"/>
               </a:rPr>
-              <a:t>Hyundai firewall</a:t>
-            </a:r>
-          </a:p>
-          <a:p>
-            <a:pPr algn="l"/>
-            <a:r>
-              <a:rPr sz="1050" b="0" i="0">
-                <a:solidFill>
-                  <a:srgbClr val="595959"/>
-                </a:solidFill>
-                <a:latin typeface="Calibri"/>
-              </a:rPr>
-              <a:t>IPsec.1 · static</a:t>
-            </a:r>
-          </a:p>
-        </p:txBody>
-      </p:sp>
-      <p:sp>
-        <p:nvSpPr>
-          <p:cNvPr id="22" name="Rounded Rectangle 21"/>
-          <p:cNvSpPr/>
-          <p:nvPr/>
-        </p:nvSpPr>
-        <p:spPr>
-          <a:xfrm>
-            <a:off x="9317736" y="3035808"/>
-            <a:ext cx="502920" cy="274320"/>
-          </a:xfrm>
-          <a:prstGeom prst="roundRect">
-            <a:avLst>
-              <a:gd name="adj" fmla="val 50000"/>
-            </a:avLst>
-          </a:prstGeom>
-          <a:solidFill>
-            <a:srgbClr val="002C5F"/>
-          </a:solidFill>
-          <a:ln>
-            <a:noFill/>
-          </a:ln>
-          <a:effectLst/>
-        </p:spPr>
-        <p:style>
-          <a:lnRef idx="1">
-            <a:schemeClr val="accent1"/>
-          </a:lnRef>
-          <a:fillRef idx="3">
-            <a:schemeClr val="accent1"/>
-          </a:fillRef>
-          <a:effectRef idx="2">
-            <a:schemeClr val="accent1"/>
-          </a:effectRef>
-          <a:fontRef idx="minor">
-            <a:schemeClr val="lt1"/>
-          </a:fontRef>
-        </p:style>
-        <p:txBody>
-          <a:bodyPr rtlCol="0" anchor="ctr" wrap="square" lIns="38100" rIns="38100"/>
-          <a:lstStyle/>
-          <a:p>
-            <a:pPr algn="ctr"/>
-            <a:r>
-              <a:rPr sz="900" b="1" i="0">
-                <a:solidFill>
-                  <a:srgbClr val="FFFFFF"/>
-                </a:solidFill>
-                <a:latin typeface="Calibri"/>
-              </a:rPr>
-              <a:t>VGW</a:t>
+              <a:t>split tunnel</a:t>
             </a:r>
           </a:p>
         </p:txBody>
       </p:sp>
       <p:cxnSp>
         <p:nvCxnSpPr>
-          <p:cNvPr id="23" name="Connector 22"/>
-          <p:cNvCxnSpPr/>
-          <p:nvPr/>
-        </p:nvCxnSpPr>
-        <p:spPr>
-          <a:xfrm>
-            <a:off x="9555480" y="2862072"/>
-            <a:ext cx="155448" cy="292608"/>
-          </a:xfrm>
-          <a:prstGeom prst="line">
-            <a:avLst/>
-          </a:prstGeom>
-          <a:ln w="22225">
-            <a:solidFill>
-              <a:srgbClr val="595959"/>
-            </a:solidFill>
-            <a:prstDash val="dash"/>
-            <a:tailEnd type="triangle" w="med" len="med"/>
-          </a:ln>
-        </p:spPr>
-        <p:style>
-          <a:lnRef idx="2">
-            <a:schemeClr val="accent1"/>
-          </a:lnRef>
-          <a:fillRef idx="0">
-            <a:schemeClr val="accent1"/>
-          </a:fillRef>
-          <a:effectRef idx="1">
-            <a:schemeClr val="accent1"/>
-          </a:effectRef>
-          <a:fontRef idx="minor">
-            <a:schemeClr val="tx1"/>
-          </a:fontRef>
-        </p:style>
-      </p:cxnSp>
-      <p:sp>
-        <p:nvSpPr>
-          <p:cNvPr id="24" name="TextBox 23"/>
-          <p:cNvSpPr txBox="1"/>
-          <p:nvPr/>
-        </p:nvSpPr>
-        <p:spPr>
-          <a:xfrm>
-            <a:off x="9464040" y="3429000"/>
-            <a:ext cx="2377440" cy="502920"/>
-          </a:xfrm>
-          <a:prstGeom prst="rect">
-            <a:avLst/>
-          </a:prstGeom>
-          <a:noFill/>
-        </p:spPr>
-        <p:txBody>
-          <a:bodyPr wrap="square" anchor="t" lIns="25400" rIns="25400" tIns="12700" bIns="12700">
-            <a:spAutoFit/>
-          </a:bodyPr>
-          <a:lstStyle/>
-          <a:p>
-            <a:pPr algn="l"/>
-            <a:r>
-              <a:rPr sz="1000" b="0" i="0">
-                <a:solidFill>
-                  <a:srgbClr val="9AA7B4"/>
-                </a:solidFill>
-                <a:latin typeface="Calibri"/>
-              </a:rPr>
-              <a:t>Site-to-Site VPN</a:t>
-            </a:r>
-          </a:p>
-          <a:p>
-            <a:pPr algn="l"/>
-            <a:r>
-              <a:rPr sz="1000" b="0" i="0">
-                <a:solidFill>
-                  <a:srgbClr val="9AA7B4"/>
-                </a:solidFill>
-                <a:latin typeface="Calibri"/>
-              </a:rPr>
-              <a:t>only when on-prem values are supplied</a:t>
-            </a:r>
-          </a:p>
-        </p:txBody>
-      </p:sp>
-      <p:sp>
-        <p:nvSpPr>
-          <p:cNvPr id="25" name="Rounded Rectangle 24"/>
-          <p:cNvSpPr/>
-          <p:nvPr/>
-        </p:nvSpPr>
-        <p:spPr>
-          <a:xfrm>
-            <a:off x="457200" y="1920240"/>
-            <a:ext cx="2011680" cy="822960"/>
-          </a:xfrm>
-          <a:prstGeom prst="roundRect">
-            <a:avLst>
-              <a:gd name="adj" fmla="val 8000"/>
-            </a:avLst>
-          </a:prstGeom>
-          <a:solidFill>
-            <a:srgbClr val="F2F2F2"/>
-          </a:solidFill>
-          <a:ln w="12700">
-            <a:solidFill>
-              <a:srgbClr val="595959"/>
-            </a:solidFill>
-          </a:ln>
-          <a:effectLst/>
-        </p:spPr>
-        <p:style>
-          <a:lnRef idx="1">
-            <a:schemeClr val="accent1"/>
-          </a:lnRef>
-          <a:fillRef idx="3">
-            <a:schemeClr val="accent1"/>
-          </a:fillRef>
-          <a:effectRef idx="2">
-            <a:schemeClr val="accent1"/>
-          </a:effectRef>
-          <a:fontRef idx="minor">
-            <a:schemeClr val="lt1"/>
-          </a:fontRef>
-        </p:style>
-        <p:txBody>
-          <a:bodyPr rtlCol="0" anchor="ctr"/>
-          <a:lstStyle/>
-          <a:p>
-            <a:pPr algn="ctr"/>
-          </a:p>
-        </p:txBody>
-      </p:sp>
-      <p:sp>
-        <p:nvSpPr>
-          <p:cNvPr id="26" name="TextBox 25"/>
-          <p:cNvSpPr txBox="1"/>
-          <p:nvPr/>
-        </p:nvSpPr>
-        <p:spPr>
-          <a:xfrm>
-            <a:off x="594360" y="2029968"/>
-            <a:ext cx="1783080" cy="274320"/>
-          </a:xfrm>
-          <a:prstGeom prst="rect">
-            <a:avLst/>
-          </a:prstGeom>
-          <a:noFill/>
-        </p:spPr>
-        <p:txBody>
-          <a:bodyPr wrap="square" anchor="t" lIns="25400" rIns="25400" tIns="12700" bIns="12700">
-            <a:spAutoFit/>
-          </a:bodyPr>
-          <a:lstStyle/>
-          <a:p>
-            <a:pPr algn="l"/>
-            <a:r>
-              <a:rPr sz="1300" b="1" i="0">
-                <a:solidFill>
-                  <a:srgbClr val="002C5F"/>
-                </a:solidFill>
-                <a:latin typeface="Calibri"/>
-              </a:rPr>
-              <a:t>Developers (≤10)</a:t>
-            </a:r>
-          </a:p>
-        </p:txBody>
-      </p:sp>
-      <p:sp>
-        <p:nvSpPr>
-          <p:cNvPr id="27" name="TextBox 26"/>
-          <p:cNvSpPr txBox="1"/>
-          <p:nvPr/>
-        </p:nvSpPr>
-        <p:spPr>
-          <a:xfrm>
-            <a:off x="594360" y="2331720"/>
-            <a:ext cx="1783080" cy="365760"/>
-          </a:xfrm>
-          <a:prstGeom prst="rect">
-            <a:avLst/>
-          </a:prstGeom>
-          <a:noFill/>
-        </p:spPr>
-        <p:txBody>
-          <a:bodyPr wrap="square" anchor="t" lIns="25400" rIns="25400" tIns="12700" bIns="12700">
-            <a:spAutoFit/>
-          </a:bodyPr>
-          <a:lstStyle/>
-          <a:p>
-            <a:pPr algn="l"/>
-            <a:r>
-              <a:rPr sz="1050" b="0" i="0">
-                <a:solidFill>
-                  <a:srgbClr val="595959"/>
-                </a:solidFill>
-                <a:latin typeface="Calibri"/>
-              </a:rPr>
-              <a:t>Entra ID SSO · MFA</a:t>
-            </a:r>
-          </a:p>
-        </p:txBody>
-      </p:sp>
-      <p:sp>
-        <p:nvSpPr>
-          <p:cNvPr id="28" name="Rounded Rectangle 27"/>
-          <p:cNvSpPr/>
-          <p:nvPr/>
-        </p:nvSpPr>
-        <p:spPr>
-          <a:xfrm>
-            <a:off x="457200" y="3291840"/>
-            <a:ext cx="2011680" cy="1005840"/>
-          </a:xfrm>
-          <a:prstGeom prst="roundRect">
-            <a:avLst>
-              <a:gd name="adj" fmla="val 8000"/>
-            </a:avLst>
-          </a:prstGeom>
-          <a:solidFill>
-            <a:srgbClr val="E8F4FA"/>
-          </a:solidFill>
-          <a:ln w="12700">
-            <a:solidFill>
-              <a:srgbClr val="007FA8"/>
-            </a:solidFill>
-          </a:ln>
-          <a:effectLst/>
-        </p:spPr>
-        <p:style>
-          <a:lnRef idx="1">
-            <a:schemeClr val="accent1"/>
-          </a:lnRef>
-          <a:fillRef idx="3">
-            <a:schemeClr val="accent1"/>
-          </a:fillRef>
-          <a:effectRef idx="2">
-            <a:schemeClr val="accent1"/>
-          </a:effectRef>
-          <a:fontRef idx="minor">
-            <a:schemeClr val="lt1"/>
-          </a:fontRef>
-        </p:style>
-        <p:txBody>
-          <a:bodyPr rtlCol="0" anchor="ctr"/>
-          <a:lstStyle/>
-          <a:p>
-            <a:pPr algn="ctr"/>
-          </a:p>
-        </p:txBody>
-      </p:sp>
-      <p:sp>
-        <p:nvSpPr>
-          <p:cNvPr id="29" name="TextBox 28"/>
-          <p:cNvSpPr txBox="1"/>
-          <p:nvPr/>
-        </p:nvSpPr>
-        <p:spPr>
-          <a:xfrm>
-            <a:off x="594360" y="3401568"/>
-            <a:ext cx="1783080" cy="274320"/>
-          </a:xfrm>
-          <a:prstGeom prst="rect">
-            <a:avLst/>
-          </a:prstGeom>
-          <a:noFill/>
-        </p:spPr>
-        <p:txBody>
-          <a:bodyPr wrap="square" anchor="t" lIns="25400" rIns="25400" tIns="12700" bIns="12700">
-            <a:spAutoFit/>
-          </a:bodyPr>
-          <a:lstStyle/>
-          <a:p>
-            <a:pPr algn="l"/>
-            <a:r>
-              <a:rPr sz="1300" b="1" i="0">
-                <a:solidFill>
-                  <a:srgbClr val="002C5F"/>
-                </a:solidFill>
-                <a:latin typeface="Calibri"/>
-              </a:rPr>
-              <a:t>AWS Client VPN</a:t>
-            </a:r>
-          </a:p>
-        </p:txBody>
-      </p:sp>
-      <p:sp>
-        <p:nvSpPr>
-          <p:cNvPr id="30" name="TextBox 29"/>
-          <p:cNvSpPr txBox="1"/>
-          <p:nvPr/>
-        </p:nvSpPr>
-        <p:spPr>
-          <a:xfrm>
-            <a:off x="594360" y="3703320"/>
-            <a:ext cx="1783080" cy="502920"/>
-          </a:xfrm>
-          <a:prstGeom prst="rect">
-            <a:avLst/>
-          </a:prstGeom>
-          <a:noFill/>
-        </p:spPr>
-        <p:txBody>
-          <a:bodyPr wrap="square" anchor="t" lIns="25400" rIns="25400" tIns="12700" bIns="12700">
-            <a:spAutoFit/>
-          </a:bodyPr>
-          <a:lstStyle/>
-          <a:p>
-            <a:pPr algn="l"/>
-            <a:r>
-              <a:rPr sz="1050" b="0" i="0">
-                <a:solidFill>
-                  <a:srgbClr val="595959"/>
-                </a:solidFill>
-                <a:latin typeface="Calibri"/>
-              </a:rPr>
-              <a:t>UDP 443 · SAML</a:t>
-            </a:r>
-          </a:p>
-          <a:p>
-            <a:pPr algn="l"/>
-            <a:r>
-              <a:rPr sz="1050" b="0" i="0">
-                <a:solidFill>
-                  <a:srgbClr val="595959"/>
-                </a:solidFill>
-                <a:latin typeface="Calibri"/>
-              </a:rPr>
-              <a:t>split tunnel</a:t>
-            </a:r>
-          </a:p>
-        </p:txBody>
-      </p:sp>
-      <p:cxnSp>
-        <p:nvCxnSpPr>
-          <p:cNvPr id="31" name="Connector 30"/>
+          <p:cNvPr id="30" name="Connector 29"/>
           <p:cNvCxnSpPr/>
           <p:nvPr/>
         </p:nvCxnSpPr>
@@ -6627,7 +6570,7 @@
       </p:cxnSp>
       <p:cxnSp>
         <p:nvCxnSpPr>
-          <p:cNvPr id="32" name="Connector 31"/>
+          <p:cNvPr id="31" name="Connector 30"/>
           <p:cNvCxnSpPr/>
           <p:nvPr/>
         </p:nvCxnSpPr>
@@ -6663,7 +6606,7 @@
       </p:cxnSp>
       <p:sp>
         <p:nvSpPr>
-          <p:cNvPr id="33" name="TextBox 32"/>
+          <p:cNvPr id="32" name="TextBox 31"/>
           <p:cNvSpPr txBox="1"/>
           <p:nvPr/>
         </p:nvSpPr>
@@ -6710,7 +6653,7 @@
       </p:sp>
       <p:sp>
         <p:nvSpPr>
-          <p:cNvPr id="34" name="TextBox 33"/>
+          <p:cNvPr id="33" name="TextBox 32"/>
           <p:cNvSpPr txBox="1"/>
           <p:nvPr/>
         </p:nvSpPr>
@@ -6745,7 +6688,7 @@
       </p:sp>
       <p:sp>
         <p:nvSpPr>
-          <p:cNvPr id="35" name="TextBox 34"/>
+          <p:cNvPr id="34" name="TextBox 33"/>
           <p:cNvSpPr txBox="1"/>
           <p:nvPr/>
         </p:nvSpPr>
@@ -9972,7 +9915,7 @@
                 </a:solidFill>
                 <a:latin typeface="Calibri"/>
               </a:rPr>
-              <a:t>Flow logs → S3; Client VPN logs → CloudWatch</a:t>
+              <a:t>Client VPN logs → CloudWatch (90 d)</a:t>
             </a:r>
           </a:p>
           <a:p>

</xml_diff>

<commit_message>
Drop explicit ClientVpnRouteVpc: AWS auto-adds the VPC CIDR route on subnet association
- ClientVpnTargetNetworkAssociation auto-creates a route to VpcCidr
  (Origin: associate-target-network); explicit ClientVpnRoute to the same
  CIDR failed the deploy with InvalidClientVpnDuplicateRoute (Route already exists)
- Remove resource from template + resource-inventory generator row
- Regression: also clean up ROLLBACK_FAILED leftovers from the failed run
</commit_message>
<xml_diff>
--- a/deliverables/AWS-Architecture-Design-Document.pptx
+++ b/deliverables/AWS-Architecture-Design-Document.pptx
@@ -3489,7 +3489,7 @@
                 </a:solidFill>
                 <a:latin typeface="Calibri"/>
               </a:rPr>
-              <a:t>Prepared by the HAEE Cloud Team · 19 August 2026</a:t>
+              <a:t>Prepared by the HAEE Cloud Team · 20 August 2026</a:t>
             </a:r>
           </a:p>
         </p:txBody>
@@ -10755,7 +10755,7 @@
                 </a:solidFill>
                 <a:latin typeface="Calibri"/>
               </a:rPr>
-              <a:t>Version-controlled in the project repository (main) · generated 19 August 2026</a:t>
+              <a:t>Version-controlled in the project repository (main) · generated 20 August 2026</a:t>
             </a:r>
           </a:p>
         </p:txBody>

</xml_diff>